<commit_message>
Fix rate-matrix convention bug in MRT calculation
- analyze_mnras_extensions.py (A-2) and advanced_pk_analysis.py built the
  rate matrix in row convention (A[i,j]=rate i->j) but applied the
  column-convention MRT formula -1^T A^{-1} P0, giving wrong MRT for
  asymmetric mass configs.
- Fixed both to column convention (A[j,i]=rate i->j), matching extract_rates
  and create_nature_figures.
- Regenerated fig4 (allometric scaling: MRT ~ mu12^1.16 mu_out^0.09 M^-1.38,
  R^2=0.30) and fig9 (MRT recovers empirical mean lifetime, R^2~1.00).
- Updated manuscript numbers/interpretation; documented Peters high-e limit.
- Rebuilt manuscript/cover letter/pptx/zip.

Co-Authored-By: Tatsuki Onishi <bougtoir@gmail.com>
</commit_message>
<xml_diff>
--- a/threebody_pk_compartment/manuscript/figures_mnras_editable.pptx
+++ b/threebody_pk_compartment/manuscript/figures_mnras_editable.pptx
@@ -3845,8 +3845,8 @@
         </p:blipFill>
         <p:spPr>
           <a:xfrm>
-            <a:off x="2627915" y="822960"/>
-            <a:ext cx="6935863" cy="4937759"/>
+            <a:off x="2617053" y="822960"/>
+            <a:ext cx="6957588" cy="4937759"/>
           </a:xfrm>
           <a:prstGeom prst="rect">
             <a:avLst/>
@@ -3877,7 +3877,7 @@
           <a:p>
             <a:r>
               <a:rPr sz="1100"/>
-              <a:t>Population-PK analysis of the mass-ratio dependence. (a) MRT versus binary–single reduced mass; (b) median lifetime versus intruder mass; (c) mean excursions versus lightest mass fraction; (d) lightest-body escape probability with logistic fit; (e) predicted versus observed MRT (R^2 = 0.67); (f) slowest half-life across the (m_2, m_3) grid.</a:t>
+              <a:t>Population-PK analysis of the mass-ratio dependence. (a) MRT versus binary–single reduced mass; (b) median lifetime versus intruder mass; (c) mean excursions versus lightest mass fraction; (d) lightest-body escape probability with logistic fit; (e) predicted versus observed MRT (R^2 = 0.30); (f) slowest half-life across the (m_2, m_3) grid.</a:t>
             </a:r>
           </a:p>
         </p:txBody>

</xml_diff>